<commit_message>
add real dashboard screenshot to slide 7; link the live deploy everywhere
figures/dashboard/01_live_view.png is a genuine screenshot of the
deployed app (captured headlessly via Playwright against the running
Streamlit server, not a mockup), showing the row picker, live reading,
alert banners, and SHAP explanation panels actually rendering.

src/generate_cse_overall_presentation.py: slide 7 now embeds this
screenshot instead of describing the dashboard in bullets only.
Re-verified visually via PowerPoint COM render-to-PNG before
committing, same as the earlier fix on this deck.

Linked the live deploy (https://fahmidaca-microgrid-dt-srcdashboard-7yxtjd.streamlit.app)
from README.md and docs/CSE_WORK_SUMMARY.md so teammates/supervisor
can open it directly without running anything locally.

Also: added ~$*.pptx/.docx/.xlsx to .gitignore - a PowerPoint lock
file from having the deck open during this session almost got staged.
</commit_message>
<xml_diff>
--- a/presentation/cse_overall_progress.pptx
+++ b/presentation/cse_overall_progress.pptx
@@ -6259,8 +6259,8 @@
         </p:nvSpPr>
         <p:spPr>
           <a:xfrm>
-            <a:off x="640080" y="1188720"/>
-            <a:ext cx="5486400" cy="365760"/>
+            <a:off x="548640" y="1170432"/>
+            <a:ext cx="5852160" cy="320040"/>
           </a:xfrm>
           <a:prstGeom prst="rect">
             <a:avLst/>
@@ -6275,27 +6275,51 @@
           <a:p>
             <a:pPr algn="l"/>
             <a:r>
-              <a:rPr sz="1400" b="1">
+              <a:rPr sz="1200" b="1">
                 <a:solidFill>
                   <a:srgbClr val="2A9D8F"/>
                 </a:solidFill>
                 <a:latin typeface="Calibri"/>
               </a:rPr>
-              <a:t>Interactive dashboard  (streamlit run src/dashboard.py)</a:t>
-            </a:r>
-          </a:p>
-        </p:txBody>
-      </p:sp>
-      <p:sp>
-        <p:nvSpPr>
-          <p:cNvPr id="6" name="TextBox 5"/>
+              <a:t>Live at streamlit.app  —  streamlit run src/dashboard.py</a:t>
+            </a:r>
+          </a:p>
+        </p:txBody>
+      </p:sp>
+      <p:pic>
+        <p:nvPicPr>
+          <p:cNvPr id="6" name="Picture 5" descr="01_live_view.png"/>
+          <p:cNvPicPr>
+            <a:picLocks noChangeAspect="1"/>
+          </p:cNvPicPr>
+          <p:nvPr/>
+        </p:nvPicPr>
+        <p:blipFill>
+          <a:blip r:embed="rId2"/>
+          <a:stretch>
+            <a:fillRect/>
+          </a:stretch>
+        </p:blipFill>
+        <p:spPr>
+          <a:xfrm>
+            <a:off x="457200" y="1508760"/>
+            <a:ext cx="5913120" cy="4434840"/>
+          </a:xfrm>
+          <a:prstGeom prst="rect">
+            <a:avLst/>
+          </a:prstGeom>
+        </p:spPr>
+      </p:pic>
+      <p:sp>
+        <p:nvSpPr>
+          <p:cNvPr id="7" name="TextBox 6"/>
           <p:cNvSpPr txBox="1"/>
           <p:nvPr/>
         </p:nvSpPr>
         <p:spPr>
           <a:xfrm>
-            <a:off x="640080" y="1645920"/>
-            <a:ext cx="5486400" cy="3200400"/>
+            <a:off x="6492240" y="1234440"/>
+            <a:ext cx="5212080" cy="1920240"/>
           </a:xfrm>
           <a:prstGeom prst="rect">
             <a:avLst/>
@@ -6310,95 +6334,79 @@
           <a:p>
             <a:pPr algn="l">
               <a:spcAft>
-                <a:spcPts val="700"/>
+                <a:spcPts val="500"/>
               </a:spcAft>
             </a:pPr>
             <a:r>
-              <a:rPr sz="1200">
+              <a:rPr sz="1100">
                 <a:solidFill>
                   <a:srgbClr val="264653"/>
                 </a:solidFill>
                 <a:latin typeface="Calibri"/>
               </a:rPr>
-              <a:t>•  Pick a row -&gt; live reading (voltage/current/THD/weather)</a:t>
+              <a:t>•  Pick a row -&gt; live reading + alert banners (disturbance classifier + anomaly detector)</a:t>
             </a:r>
           </a:p>
           <a:p>
             <a:pPr algn="l">
               <a:spcAft>
-                <a:spcPts val="700"/>
+                <a:spcPts val="500"/>
               </a:spcAft>
             </a:pPr>
             <a:r>
-              <a:rPr sz="1200">
+              <a:rPr sz="1100">
                 <a:solidFill>
                   <a:srgbClr val="264653"/>
                 </a:solidFill>
                 <a:latin typeface="Calibri"/>
               </a:rPr>
-              <a:t>•  Alert banners from BOTH the disturbance classifier and the anomaly detector</a:t>
+              <a:t>•  Live SHAP explanation for that specific row</a:t>
             </a:r>
           </a:p>
           <a:p>
             <a:pPr algn="l">
               <a:spcAft>
-                <a:spcPts val="700"/>
+                <a:spcPts val="500"/>
               </a:spcAft>
             </a:pPr>
             <a:r>
-              <a:rPr sz="1200">
+              <a:rPr sz="1100">
                 <a:solidFill>
                   <a:srgbClr val="264653"/>
                 </a:solidFill>
                 <a:latin typeface="Calibri"/>
               </a:rPr>
-              <a:t>•  Live SHAP explanation for that specific row, not just an aggregate plot</a:t>
+              <a:t>•  Cost panel labelled team-calculated, not measured</a:t>
             </a:r>
           </a:p>
           <a:p>
             <a:pPr algn="l">
               <a:spcAft>
-                <a:spcPts val="700"/>
+                <a:spcPts val="500"/>
               </a:spcAft>
             </a:pPr>
             <a:r>
-              <a:rPr sz="1200">
+              <a:rPr sz="1100">
                 <a:solidFill>
                   <a:srgbClr val="264653"/>
                 </a:solidFill>
                 <a:latin typeface="Calibri"/>
               </a:rPr>
-              <a:t>•  Cost-impact panel — explicitly labelled as team-calculated, not measured</a:t>
-            </a:r>
-          </a:p>
-          <a:p>
-            <a:pPr algn="l">
-              <a:spcAft>
-                <a:spcPts val="700"/>
-              </a:spcAft>
-            </a:pPr>
-            <a:r>
-              <a:rPr sz="1200">
-                <a:solidFill>
-                  <a:srgbClr val="264653"/>
-                </a:solidFill>
-                <a:latin typeface="Calibri"/>
-              </a:rPr>
-              <a:t>•  Historical trend chart with disturbance rows colour-coded</a:t>
-            </a:r>
-          </a:p>
-        </p:txBody>
-      </p:sp>
-      <p:sp>
-        <p:nvSpPr>
-          <p:cNvPr id="7" name="Rounded Rectangle 6"/>
+              <a:t>•  Historical trend, disturbance rows colour-coded</a:t>
+            </a:r>
+          </a:p>
+        </p:txBody>
+      </p:sp>
+      <p:sp>
+        <p:nvSpPr>
+          <p:cNvPr id="8" name="Rounded Rectangle 7"/>
           <p:cNvSpPr/>
           <p:nvPr/>
         </p:nvSpPr>
         <p:spPr>
           <a:xfrm>
-            <a:off x="6400800" y="1188720"/>
-            <a:ext cx="5303520" cy="3657600"/>
+            <a:off x="6492240" y="3246120"/>
+            <a:ext cx="5212080" cy="2743200"/>
           </a:xfrm>
           <a:prstGeom prst="roundRect">
             <a:avLst/>
@@ -6432,7 +6440,7 @@
           <a:p>
             <a:pPr algn="l"/>
             <a:r>
-              <a:rPr b="1" sz="1500">
+              <a:rPr b="1" sz="1400">
                 <a:solidFill>
                   <a:srgbClr val="FFFFFF"/>
                 </a:solidFill>
@@ -6444,7 +6452,7 @@
           <a:p>
             <a:pPr algn="l"/>
             <a:r>
-              <a:rPr sz="1200">
+              <a:rPr sz="1100">
                 <a:solidFill>
                   <a:srgbClr val="FFFFFF"/>
                 </a:solidFill>
@@ -6456,31 +6464,31 @@
           <a:p>
             <a:pPr algn="l"/>
             <a:r>
-              <a:rPr sz="1200">
+              <a:rPr sz="1100">
                 <a:solidFill>
                   <a:srgbClr val="FFFFFF"/>
                 </a:solidFill>
                 <a:latin typeface="Calibri"/>
               </a:rPr>
-              <a:t>Team confirmed: electrical readings are field-</a:t>
+              <a:t>Team confirmed: electrical readings are</a:t>
             </a:r>
           </a:p>
           <a:p>
             <a:pPr algn="l"/>
             <a:r>
-              <a:rPr sz="1200">
+              <a:rPr sz="1100">
                 <a:solidFill>
                   <a:srgbClr val="FFFFFF"/>
                 </a:solidFill>
                 <a:latin typeface="Calibri"/>
               </a:rPr>
-              <a:t>measured at the Jamalpur powerplant site.</a:t>
+              <a:t>field-measured at the Jamalpur site.</a:t>
             </a:r>
           </a:p>
           <a:p>
             <a:pPr algn="l"/>
             <a:r>
-              <a:rPr sz="1200">
+              <a:rPr sz="1100">
                 <a:solidFill>
                   <a:srgbClr val="FFFFFF"/>
                 </a:solidFill>
@@ -6492,68 +6500,56 @@
           <a:p>
             <a:pPr algn="l"/>
             <a:r>
-              <a:rPr sz="1200">
+              <a:rPr sz="1100">
                 <a:solidFill>
                   <a:srgbClr val="FFFFFF"/>
                 </a:solidFill>
                 <a:latin typeface="Calibri"/>
               </a:rPr>
-              <a:t>Still true regardless: economic_cost_BDT and</a:t>
+              <a:t>Still true regardless: economic_cost_BDT</a:t>
             </a:r>
           </a:p>
           <a:p>
             <a:pPr algn="l"/>
             <a:r>
-              <a:rPr sz="1200">
+              <a:rPr sz="1100">
                 <a:solidFill>
                   <a:srgbClr val="FFFFFF"/>
                 </a:solidFill>
                 <a:latin typeface="Calibri"/>
               </a:rPr>
-              <a:t>battery_capacity_loss_pct are team-calculated</a:t>
+              <a:t>and battery_capacity_loss_pct are team-</a:t>
             </a:r>
           </a:p>
           <a:p>
             <a:pPr algn="l"/>
             <a:r>
-              <a:rPr sz="1200">
+              <a:rPr sz="1100">
                 <a:solidFill>
                   <a:srgbClr val="FFFFFF"/>
                 </a:solidFill>
                 <a:latin typeface="Calibri"/>
               </a:rPr>
-              <a:t>columns, not independent measurements —</a:t>
+              <a:t>calculated, not independent measurements —</a:t>
             </a:r>
           </a:p>
           <a:p>
             <a:pPr algn="l"/>
             <a:r>
-              <a:rPr sz="1200">
+              <a:rPr sz="1100">
                 <a:solidFill>
                   <a:srgbClr val="FFFFFF"/>
                 </a:solidFill>
                 <a:latin typeface="Calibri"/>
               </a:rPr>
-              <a:t>documented column-by-column so the paper</a:t>
-            </a:r>
-          </a:p>
-          <a:p>
-            <a:pPr algn="l"/>
-            <a:r>
-              <a:rPr sz="1200">
-                <a:solidFill>
-                  <a:srgbClr val="FFFFFF"/>
-                </a:solidFill>
-                <a:latin typeface="Calibri"/>
-              </a:rPr>
-              <a:t>describes each one correctly.</a:t>
-            </a:r>
-          </a:p>
-        </p:txBody>
-      </p:sp>
-      <p:sp>
-        <p:nvSpPr>
-          <p:cNvPr id="8" name="TextBox 7"/>
+              <a:t>documented column-by-column.</a:t>
+            </a:r>
+          </a:p>
+        </p:txBody>
+      </p:sp>
+      <p:sp>
+        <p:nvSpPr>
+          <p:cNvPr id="9" name="TextBox 8"/>
           <p:cNvSpPr txBox="1"/>
           <p:nvPr/>
         </p:nvSpPr>
@@ -6588,7 +6584,7 @@
       </p:sp>
       <p:sp>
         <p:nvSpPr>
-          <p:cNvPr id="9" name="TextBox 8"/>
+          <p:cNvPr id="10" name="TextBox 9"/>
           <p:cNvSpPr txBox="1"/>
           <p:nvPr/>
         </p:nvSpPr>

</xml_diff>